<commit_message>
Updated opportunities in the presentation
</commit_message>
<xml_diff>
--- a/Inventory_Management_System.pptx
+++ b/Inventory_Management_System.pptx
@@ -145,7 +145,7 @@
 <file path=ppt/revisionInfo.xml><?xml version="1.0" encoding="utf-8"?>
 <p1510:revInfo xmlns:a="http://schemas.openxmlformats.org/drawingml/2006/main" xmlns:r="http://schemas.openxmlformats.org/officeDocument/2006/relationships" xmlns:p1510="http://schemas.microsoft.com/office/powerpoint/2015/10/main">
   <p1510:revLst>
-    <p1510:client id="{5816BE70-0E7B-4F76-9B9A-339FBF9AAFBE}" v="5" dt="2026-04-24T20:40:22.041"/>
+    <p1510:client id="{5816BE70-0E7B-4F76-9B9A-339FBF9AAFBE}" v="7" dt="2026-04-25T07:24:56.884"/>
   </p1510:revLst>
 </p1510:revInfo>
 </file>
@@ -155,7 +155,7 @@
   <pc:docChgLst>
     <pc:chgData name="Olamide Adeboye" userId="9e787034137b2853" providerId="LiveId" clId="{7D6CD3DA-39E8-4DBC-AE6D-988E01832CC9}"/>
     <pc:docChg chg="undo redo custSel addSld delSld modSld">
-      <pc:chgData name="Olamide Adeboye" userId="9e787034137b2853" providerId="LiveId" clId="{7D6CD3DA-39E8-4DBC-AE6D-988E01832CC9}" dt="2026-04-24T20:43:26.228" v="407" actId="20577"/>
+      <pc:chgData name="Olamide Adeboye" userId="9e787034137b2853" providerId="LiveId" clId="{7D6CD3DA-39E8-4DBC-AE6D-988E01832CC9}" dt="2026-04-25T07:25:54.200" v="561" actId="108"/>
       <pc:docMkLst>
         <pc:docMk/>
       </pc:docMkLst>
@@ -262,11 +262,19 @@
         </pc:sldMkLst>
       </pc:sldChg>
       <pc:sldChg chg="modSp mod modNotesTx">
-        <pc:chgData name="Olamide Adeboye" userId="9e787034137b2853" providerId="LiveId" clId="{7D6CD3DA-39E8-4DBC-AE6D-988E01832CC9}" dt="2026-04-24T20:42:34.298" v="403" actId="20577"/>
+        <pc:chgData name="Olamide Adeboye" userId="9e787034137b2853" providerId="LiveId" clId="{7D6CD3DA-39E8-4DBC-AE6D-988E01832CC9}" dt="2026-04-25T07:25:54.200" v="561" actId="108"/>
         <pc:sldMkLst>
           <pc:docMk/>
           <pc:sldMk cId="0" sldId="269"/>
         </pc:sldMkLst>
+        <pc:spChg chg="mod">
+          <ac:chgData name="Olamide Adeboye" userId="9e787034137b2853" providerId="LiveId" clId="{7D6CD3DA-39E8-4DBC-AE6D-988E01832CC9}" dt="2026-04-25T07:25:54.200" v="561" actId="108"/>
+          <ac:spMkLst>
+            <pc:docMk/>
+            <pc:sldMk cId="0" sldId="269"/>
+            <ac:spMk id="7" creationId="{00000000-0000-0000-0000-000000000000}"/>
+          </ac:spMkLst>
+        </pc:spChg>
         <pc:spChg chg="mod">
           <ac:chgData name="Olamide Adeboye" userId="9e787034137b2853" providerId="LiveId" clId="{7D6CD3DA-39E8-4DBC-AE6D-988E01832CC9}" dt="2026-04-24T20:42:34.298" v="403" actId="20577"/>
           <ac:spMkLst>
@@ -759,7 +767,7 @@
           <a:p>
             <a:fld id="{6FB49FE8-59AD-4B3E-B77C-CD46C2740DFC}" type="datetimeFigureOut">
               <a:rPr lang="en-GB" smtClean="0"/>
-              <a:t>24/04/2026</a:t>
+              <a:t>25/04/2026</a:t>
             </a:fld>
             <a:endParaRPr lang="en-GB"/>
           </a:p>
@@ -8273,7 +8281,7 @@
           <a:p>
             <a:fld id="{5BCAD085-E8A6-8845-BD4E-CB4CCA059FC4}" type="datetimeFigureOut">
               <a:rPr lang="en-US" smtClean="0"/>
-              <a:t>4/24/2026</a:t>
+              <a:t>4/25/2026</a:t>
             </a:fld>
             <a:endParaRPr lang="en-US"/>
           </a:p>
@@ -8441,7 +8449,7 @@
           <a:p>
             <a:fld id="{5BCAD085-E8A6-8845-BD4E-CB4CCA059FC4}" type="datetimeFigureOut">
               <a:rPr lang="en-US" smtClean="0"/>
-              <a:t>4/24/2026</a:t>
+              <a:t>4/25/2026</a:t>
             </a:fld>
             <a:endParaRPr lang="en-US"/>
           </a:p>
@@ -8619,7 +8627,7 @@
           <a:p>
             <a:fld id="{5BCAD085-E8A6-8845-BD4E-CB4CCA059FC4}" type="datetimeFigureOut">
               <a:rPr lang="en-US" smtClean="0"/>
-              <a:t>4/24/2026</a:t>
+              <a:t>4/25/2026</a:t>
             </a:fld>
             <a:endParaRPr lang="en-US"/>
           </a:p>
@@ -8787,7 +8795,7 @@
           <a:p>
             <a:fld id="{5BCAD085-E8A6-8845-BD4E-CB4CCA059FC4}" type="datetimeFigureOut">
               <a:rPr lang="en-US" smtClean="0"/>
-              <a:t>4/24/2026</a:t>
+              <a:t>4/25/2026</a:t>
             </a:fld>
             <a:endParaRPr lang="en-US"/>
           </a:p>
@@ -9032,7 +9040,7 @@
           <a:p>
             <a:fld id="{5BCAD085-E8A6-8845-BD4E-CB4CCA059FC4}" type="datetimeFigureOut">
               <a:rPr lang="en-US" smtClean="0"/>
-              <a:t>4/24/2026</a:t>
+              <a:t>4/25/2026</a:t>
             </a:fld>
             <a:endParaRPr lang="en-US"/>
           </a:p>
@@ -9317,7 +9325,7 @@
           <a:p>
             <a:fld id="{5BCAD085-E8A6-8845-BD4E-CB4CCA059FC4}" type="datetimeFigureOut">
               <a:rPr lang="en-US" smtClean="0"/>
-              <a:t>4/24/2026</a:t>
+              <a:t>4/25/2026</a:t>
             </a:fld>
             <a:endParaRPr lang="en-US"/>
           </a:p>
@@ -9736,7 +9744,7 @@
           <a:p>
             <a:fld id="{5BCAD085-E8A6-8845-BD4E-CB4CCA059FC4}" type="datetimeFigureOut">
               <a:rPr lang="en-US" smtClean="0"/>
-              <a:t>4/24/2026</a:t>
+              <a:t>4/25/2026</a:t>
             </a:fld>
             <a:endParaRPr lang="en-US"/>
           </a:p>
@@ -9853,7 +9861,7 @@
           <a:p>
             <a:fld id="{5BCAD085-E8A6-8845-BD4E-CB4CCA059FC4}" type="datetimeFigureOut">
               <a:rPr lang="en-US" smtClean="0"/>
-              <a:t>4/24/2026</a:t>
+              <a:t>4/25/2026</a:t>
             </a:fld>
             <a:endParaRPr lang="en-US"/>
           </a:p>
@@ -9948,7 +9956,7 @@
           <a:p>
             <a:fld id="{5BCAD085-E8A6-8845-BD4E-CB4CCA059FC4}" type="datetimeFigureOut">
               <a:rPr lang="en-US" smtClean="0"/>
-              <a:t>4/24/2026</a:t>
+              <a:t>4/25/2026</a:t>
             </a:fld>
             <a:endParaRPr lang="en-US"/>
           </a:p>
@@ -10223,7 +10231,7 @@
           <a:p>
             <a:fld id="{5BCAD085-E8A6-8845-BD4E-CB4CCA059FC4}" type="datetimeFigureOut">
               <a:rPr lang="en-US" smtClean="0"/>
-              <a:t>4/24/2026</a:t>
+              <a:t>4/25/2026</a:t>
             </a:fld>
             <a:endParaRPr lang="en-US"/>
           </a:p>
@@ -10475,7 +10483,7 @@
           <a:p>
             <a:fld id="{5BCAD085-E8A6-8845-BD4E-CB4CCA059FC4}" type="datetimeFigureOut">
               <a:rPr lang="en-US" smtClean="0"/>
-              <a:t>4/24/2026</a:t>
+              <a:t>4/25/2026</a:t>
             </a:fld>
             <a:endParaRPr lang="en-US"/>
           </a:p>
@@ -10686,7 +10694,7 @@
           <a:p>
             <a:fld id="{5BCAD085-E8A6-8845-BD4E-CB4CCA059FC4}" type="datetimeFigureOut">
               <a:rPr lang="en-US" smtClean="0"/>
-              <a:t>4/24/2026</a:t>
+              <a:t>4/25/2026</a:t>
             </a:fld>
             <a:endParaRPr lang="en-US"/>
           </a:p>
@@ -15487,8 +15495,79 @@
           <a:bodyPr rtlCol="0" anchor="ctr"/>
           <a:lstStyle/>
           <a:p>
-            <a:pPr algn="ctr"/>
-            <a:endParaRPr/>
+            <a:br>
+              <a:rPr lang="en-US" b="1" dirty="0">
+                <a:solidFill>
+                  <a:srgbClr val="0E3B66"/>
+                </a:solidFill>
+              </a:rPr>
+            </a:br>
+            <a:br>
+              <a:rPr lang="en-US" b="1" dirty="0">
+                <a:solidFill>
+                  <a:srgbClr val="0E3B66"/>
+                </a:solidFill>
+              </a:rPr>
+            </a:br>
+            <a:r>
+              <a:rPr lang="en-US" b="1" dirty="0">
+                <a:solidFill>
+                  <a:srgbClr val="0E3B66"/>
+                </a:solidFill>
+              </a:rPr>
+              <a:t>O</a:t>
+            </a:r>
+            <a:r>
+              <a:rPr lang="en-GB" b="1" dirty="0" err="1">
+                <a:solidFill>
+                  <a:srgbClr val="0E3B66"/>
+                </a:solidFill>
+              </a:rPr>
+              <a:t>pportunities</a:t>
+            </a:r>
+            <a:endParaRPr lang="en-GB" b="1" dirty="0">
+              <a:solidFill>
+                <a:srgbClr val="0E3B66"/>
+              </a:solidFill>
+            </a:endParaRPr>
+          </a:p>
+          <a:p>
+            <a:pPr>
+              <a:spcAft>
+                <a:spcPts val="400"/>
+              </a:spcAft>
+            </a:pPr>
+            <a:r>
+              <a:rPr lang="en-US" b="1" dirty="0">
+                <a:solidFill>
+                  <a:srgbClr val="F4A261"/>
+                </a:solidFill>
+              </a:rPr>
+              <a:t>■  </a:t>
+            </a:r>
+            <a:r>
+              <a:rPr lang="en-US" sz="1400" dirty="0">
+                <a:solidFill>
+                  <a:srgbClr val="1F2D3D"/>
+                </a:solidFill>
+                <a:latin typeface="Calibri"/>
+              </a:rPr>
+              <a:t>Building a proper graphical interface for this with good UI and UX.</a:t>
+            </a:r>
+          </a:p>
+          <a:p>
+            <a:endParaRPr lang="en-GB" b="1" dirty="0">
+              <a:solidFill>
+                <a:srgbClr val="0E3B66"/>
+              </a:solidFill>
+            </a:endParaRPr>
+          </a:p>
+          <a:p>
+            <a:endParaRPr lang="en-GB" b="1" dirty="0">
+              <a:solidFill>
+                <a:srgbClr val="0E3B66"/>
+              </a:solidFill>
+            </a:endParaRPr>
           </a:p>
         </p:txBody>
       </p:sp>
@@ -15516,7 +15595,7 @@
           <a:p>
             <a:pPr algn="l"/>
             <a:r>
-              <a:rPr sz="2000" b="1">
+              <a:rPr sz="2000" b="1" dirty="0">
                 <a:solidFill>
                   <a:srgbClr val="0E3B66"/>
                 </a:solidFill>

</xml_diff>